<commit_message>
Refactor ADC2026 transcript: Enhance clarity and structure, update statistics, and improve presentation flow. Add detailed explanations of E Don Kast's functionality and implementation phases. Include Q&A section with prepared responses for anticipated questions.
</commit_message>
<xml_diff>
--- a/ADC2026_EDonKast_Deck_v2.pptx
+++ b/ADC2026_EDonKast_Deck_v2.pptx
@@ -2035,7 +2035,7 @@
                 <a:ea typeface="Calibri" pitchFamily="34" charset="-122"/>
                 <a:cs typeface="Calibri" pitchFamily="34" charset="-120"/>
               </a:rPr>
-              <a:t>Nigeria's 2023 Presidential Election  ·  Checks &amp; Accountability</a:t>
+              <a:t>Nigeria's 2023 Presidential Election  ·  Checks &amp; Accountability  ·  Majority Rules, Not Manipulation</a:t>
             </a:r>
             <a:endParaRPr lang="en-US" sz="900" dirty="0"/>
           </a:p>
@@ -2050,7 +2050,7 @@
         <p:spPr>
           <a:xfrm>
             <a:off x="365760" y="594360"/>
-            <a:ext cx="8412480" cy="749808"/>
+            <a:ext cx="5669280" cy="402336"/>
           </a:xfrm>
           <a:prstGeom prst="rect">
             <a:avLst/>
@@ -2088,6 +2088,89 @@
         </p:nvSpPr>
         <p:spPr>
           <a:xfrm>
+            <a:off x="6309360" y="566928"/>
+            <a:ext cx="2468880" cy="804672"/>
+          </a:xfrm>
+          <a:prstGeom prst="rect">
+            <a:avLst/>
+          </a:prstGeom>
+          <a:solidFill>
+            <a:srgbClr val="0B1F3A"/>
+          </a:solidFill>
+          <a:ln/>
+          <a:effectLst>
+            <a:outerShdw sx="100000" sy="100000" kx="0" ky="0" algn="bl" rotWithShape="0" blurRad="101600" dist="38100" dir="8100000">
+              <a:srgbClr val="000000">
+                <a:alpha val="12000"/>
+              </a:srgbClr>
+            </a:outerShdw>
+          </a:effectLst>
+        </p:spPr>
+      </p:sp>
+      <p:sp>
+        <p:nvSpPr>
+          <p:cNvPr id="6" name="Text 4"/>
+          <p:cNvSpPr/>
+          <p:nvPr/>
+        </p:nvSpPr>
+        <p:spPr>
+          <a:xfrm>
+            <a:off x="6400800" y="585216"/>
+            <a:ext cx="2286000" cy="768096"/>
+          </a:xfrm>
+          <a:prstGeom prst="rect">
+            <a:avLst/>
+          </a:prstGeom>
+          <a:noFill/>
+          <a:ln/>
+        </p:spPr>
+        <p:txBody>
+          <a:bodyPr wrap="square" lIns="50800" tIns="50800" rIns="50800" bIns="50800" rtlCol="0" anchor="ctr"/>
+          <a:lstStyle/>
+          <a:p>
+            <a:pPr algn="l" indent="0" marL="0">
+              <a:buNone/>
+            </a:pPr>
+            <a:r>
+              <a:rPr lang="en-US" sz="850" b="1" dirty="0">
+                <a:solidFill>
+                  <a:srgbClr val="00A99D"/>
+                </a:solidFill>
+                <a:latin typeface="Calibri" pitchFamily="34" charset="0"/>
+                <a:ea typeface="Calibri" pitchFamily="34" charset="-122"/>
+                <a:cs typeface="Calibri" pitchFamily="34" charset="-120"/>
+              </a:rPr>
+              <a:t>Track 3 core:</a:t>
+            </a:r>
+            <a:endParaRPr lang="en-US" sz="850" dirty="0"/>
+          </a:p>
+          <a:p>
+            <a:pPr algn="l" indent="0" marL="0">
+              <a:buNone/>
+            </a:pPr>
+            <a:r>
+              <a:rPr lang="en-US" sz="850" b="1" dirty="0">
+                <a:solidFill>
+                  <a:srgbClr val="00A99D"/>
+                </a:solidFill>
+                <a:latin typeface="Calibri" pitchFamily="34" charset="0"/>
+                <a:ea typeface="Calibri" pitchFamily="34" charset="-122"/>
+                <a:cs typeface="Calibri" pitchFamily="34" charset="-120"/>
+              </a:rPr>
+              <a:t>Majority rules — not manipulation, not litigation.</a:t>
+            </a:r>
+            <a:endParaRPr lang="en-US" sz="850" dirty="0"/>
+          </a:p>
+        </p:txBody>
+      </p:sp>
+      <p:sp>
+        <p:nvSpPr>
+          <p:cNvPr id="7" name="Shape 5"/>
+          <p:cNvSpPr/>
+          <p:nvPr/>
+        </p:nvSpPr>
+        <p:spPr>
+          <a:xfrm>
             <a:off x="365760" y="1316736"/>
             <a:ext cx="8412480" cy="36576"/>
           </a:xfrm>
@@ -2102,7 +2185,7 @@
       </p:sp>
       <p:sp>
         <p:nvSpPr>
-          <p:cNvPr id="6" name="Shape 4"/>
+          <p:cNvPr id="8" name="Shape 6"/>
           <p:cNvSpPr/>
           <p:nvPr/>
         </p:nvSpPr>
@@ -2134,7 +2217,7 @@
       </p:sp>
       <p:sp>
         <p:nvSpPr>
-          <p:cNvPr id="7" name="Text 5"/>
+          <p:cNvPr id="9" name="Text 7"/>
           <p:cNvSpPr/>
           <p:nvPr/>
         </p:nvSpPr>
@@ -2173,7 +2256,7 @@
       </p:sp>
       <p:sp>
         <p:nvSpPr>
-          <p:cNvPr id="8" name="Text 6"/>
+          <p:cNvPr id="10" name="Text 8"/>
           <p:cNvSpPr/>
           <p:nvPr/>
         </p:nvSpPr>
@@ -2212,7 +2295,7 @@
       </p:sp>
       <p:sp>
         <p:nvSpPr>
-          <p:cNvPr id="9" name="Text 7"/>
+          <p:cNvPr id="11" name="Text 9"/>
           <p:cNvSpPr/>
           <p:nvPr/>
         </p:nvSpPr>
@@ -2251,7 +2334,7 @@
       </p:sp>
       <p:sp>
         <p:nvSpPr>
-          <p:cNvPr id="10" name="Shape 8"/>
+          <p:cNvPr id="12" name="Shape 10"/>
           <p:cNvSpPr/>
           <p:nvPr/>
         </p:nvSpPr>
@@ -2278,7 +2361,7 @@
       </p:sp>
       <p:sp>
         <p:nvSpPr>
-          <p:cNvPr id="11" name="Text 9"/>
+          <p:cNvPr id="13" name="Text 11"/>
           <p:cNvSpPr/>
           <p:nvPr/>
         </p:nvSpPr>
@@ -2317,7 +2400,7 @@
       </p:sp>
       <p:sp>
         <p:nvSpPr>
-          <p:cNvPr id="12" name="Shape 10"/>
+          <p:cNvPr id="14" name="Shape 12"/>
           <p:cNvSpPr/>
           <p:nvPr/>
         </p:nvSpPr>
@@ -2337,7 +2420,7 @@
       </p:sp>
       <p:sp>
         <p:nvSpPr>
-          <p:cNvPr id="13" name="Text 11"/>
+          <p:cNvPr id="15" name="Text 13"/>
           <p:cNvSpPr/>
           <p:nvPr/>
         </p:nvSpPr>
@@ -2376,7 +2459,7 @@
       </p:sp>
       <p:sp>
         <p:nvSpPr>
-          <p:cNvPr id="14" name="Shape 12"/>
+          <p:cNvPr id="16" name="Shape 14"/>
           <p:cNvSpPr/>
           <p:nvPr/>
         </p:nvSpPr>
@@ -2408,7 +2491,7 @@
       </p:sp>
       <p:sp>
         <p:nvSpPr>
-          <p:cNvPr id="15" name="Text 13"/>
+          <p:cNvPr id="17" name="Text 15"/>
           <p:cNvSpPr/>
           <p:nvPr/>
         </p:nvSpPr>
@@ -2447,7 +2530,7 @@
       </p:sp>
       <p:sp>
         <p:nvSpPr>
-          <p:cNvPr id="16" name="Shape 14"/>
+          <p:cNvPr id="18" name="Shape 16"/>
           <p:cNvSpPr/>
           <p:nvPr/>
         </p:nvSpPr>
@@ -2474,7 +2557,7 @@
       </p:sp>
       <p:sp>
         <p:nvSpPr>
-          <p:cNvPr id="17" name="Text 15"/>
+          <p:cNvPr id="19" name="Text 17"/>
           <p:cNvSpPr/>
           <p:nvPr/>
         </p:nvSpPr>
@@ -2513,7 +2596,7 @@
       </p:sp>
       <p:sp>
         <p:nvSpPr>
-          <p:cNvPr id="18" name="Text 16"/>
+          <p:cNvPr id="20" name="Text 18"/>
           <p:cNvSpPr/>
           <p:nvPr/>
         </p:nvSpPr>
@@ -2552,7 +2635,7 @@
       </p:sp>
       <p:sp>
         <p:nvSpPr>
-          <p:cNvPr id="19" name="Text 17"/>
+          <p:cNvPr id="21" name="Text 19"/>
           <p:cNvSpPr/>
           <p:nvPr/>
         </p:nvSpPr>
@@ -2591,7 +2674,7 @@
       </p:sp>
       <p:sp>
         <p:nvSpPr>
-          <p:cNvPr id="20" name="Shape 18"/>
+          <p:cNvPr id="22" name="Shape 20"/>
           <p:cNvSpPr/>
           <p:nvPr/>
         </p:nvSpPr>
@@ -2611,7 +2694,7 @@
       </p:sp>
       <p:sp>
         <p:nvSpPr>
-          <p:cNvPr id="21" name="Shape 19"/>
+          <p:cNvPr id="23" name="Shape 21"/>
           <p:cNvSpPr/>
           <p:nvPr/>
         </p:nvSpPr>
@@ -2638,7 +2721,7 @@
       </p:sp>
       <p:sp>
         <p:nvSpPr>
-          <p:cNvPr id="22" name="Text 20"/>
+          <p:cNvPr id="24" name="Text 22"/>
           <p:cNvSpPr/>
           <p:nvPr/>
         </p:nvSpPr>
@@ -2677,7 +2760,7 @@
       </p:sp>
       <p:sp>
         <p:nvSpPr>
-          <p:cNvPr id="23" name="Text 21"/>
+          <p:cNvPr id="25" name="Text 23"/>
           <p:cNvSpPr/>
           <p:nvPr/>
         </p:nvSpPr>
@@ -2716,7 +2799,7 @@
       </p:sp>
       <p:sp>
         <p:nvSpPr>
-          <p:cNvPr id="24" name="Text 22"/>
+          <p:cNvPr id="26" name="Text 24"/>
           <p:cNvSpPr/>
           <p:nvPr/>
         </p:nvSpPr>
@@ -2755,7 +2838,7 @@
       </p:sp>
       <p:sp>
         <p:nvSpPr>
-          <p:cNvPr id="25" name="Shape 23"/>
+          <p:cNvPr id="27" name="Shape 25"/>
           <p:cNvSpPr/>
           <p:nvPr/>
         </p:nvSpPr>
@@ -2775,7 +2858,7 @@
       </p:sp>
       <p:sp>
         <p:nvSpPr>
-          <p:cNvPr id="26" name="Shape 24"/>
+          <p:cNvPr id="28" name="Shape 26"/>
           <p:cNvSpPr/>
           <p:nvPr/>
         </p:nvSpPr>
@@ -2802,7 +2885,7 @@
       </p:sp>
       <p:sp>
         <p:nvSpPr>
-          <p:cNvPr id="27" name="Text 25"/>
+          <p:cNvPr id="29" name="Text 27"/>
           <p:cNvSpPr/>
           <p:nvPr/>
         </p:nvSpPr>
@@ -2841,7 +2924,7 @@
       </p:sp>
       <p:sp>
         <p:nvSpPr>
-          <p:cNvPr id="28" name="Text 26"/>
+          <p:cNvPr id="30" name="Text 28"/>
           <p:cNvSpPr/>
           <p:nvPr/>
         </p:nvSpPr>
@@ -2880,7 +2963,7 @@
       </p:sp>
       <p:sp>
         <p:nvSpPr>
-          <p:cNvPr id="29" name="Text 27"/>
+          <p:cNvPr id="31" name="Text 29"/>
           <p:cNvSpPr/>
           <p:nvPr/>
         </p:nvSpPr>
@@ -2919,7 +3002,7 @@
       </p:sp>
       <p:sp>
         <p:nvSpPr>
-          <p:cNvPr id="30" name="Shape 28"/>
+          <p:cNvPr id="32" name="Shape 30"/>
           <p:cNvSpPr/>
           <p:nvPr/>
         </p:nvSpPr>
@@ -2939,7 +3022,7 @@
       </p:sp>
       <p:sp>
         <p:nvSpPr>
-          <p:cNvPr id="31" name="Text 29"/>
+          <p:cNvPr id="33" name="Text 31"/>
           <p:cNvSpPr/>
           <p:nvPr/>
         </p:nvSpPr>
@@ -2978,7 +3061,7 @@
       </p:sp>
       <p:sp>
         <p:nvSpPr>
-          <p:cNvPr id="32" name="Shape 30"/>
+          <p:cNvPr id="34" name="Shape 32"/>
           <p:cNvSpPr/>
           <p:nvPr/>
         </p:nvSpPr>
@@ -2998,7 +3081,7 @@
       </p:sp>
       <p:sp>
         <p:nvSpPr>
-          <p:cNvPr id="33" name="Text 31"/>
+          <p:cNvPr id="35" name="Text 33"/>
           <p:cNvSpPr/>
           <p:nvPr/>
         </p:nvSpPr>
@@ -6795,8 +6878,67 @@
         </p:nvSpPr>
         <p:spPr>
           <a:xfrm>
-            <a:off x="365760" y="4553712"/>
-            <a:ext cx="8412480" cy="365760"/>
+            <a:off x="365760" y="4407408"/>
+            <a:ext cx="8412480" cy="201168"/>
+          </a:xfrm>
+          <a:prstGeom prst="rect">
+            <a:avLst/>
+          </a:prstGeom>
+          <a:solidFill>
+            <a:srgbClr val="0F2740"/>
+          </a:solidFill>
+          <a:ln/>
+        </p:spPr>
+      </p:sp>
+      <p:sp>
+        <p:nvSpPr>
+          <p:cNvPr id="45" name="Text 43"/>
+          <p:cNvSpPr/>
+          <p:nvPr/>
+        </p:nvSpPr>
+        <p:spPr>
+          <a:xfrm>
+            <a:off x="502920" y="4425696"/>
+            <a:ext cx="8229600" cy="164592"/>
+          </a:xfrm>
+          <a:prstGeom prst="rect">
+            <a:avLst/>
+          </a:prstGeom>
+          <a:noFill/>
+          <a:ln/>
+        </p:spPr>
+        <p:txBody>
+          <a:bodyPr wrap="square" lIns="0" tIns="0" rIns="0" bIns="0" rtlCol="0" anchor="ctr"/>
+          <a:lstStyle/>
+          <a:p>
+            <a:pPr algn="ctr" indent="0" marL="0">
+              <a:buNone/>
+            </a:pPr>
+            <a:r>
+              <a:rPr lang="en-US" sz="800" dirty="0">
+                <a:solidFill>
+                  <a:srgbClr val="D4EBEA"/>
+                </a:solidFill>
+                <a:latin typeface="Calibri" pitchFamily="34" charset="0"/>
+                <a:ea typeface="Calibri" pitchFamily="34" charset="-122"/>
+                <a:cs typeface="Calibri" pitchFamily="34" charset="-120"/>
+              </a:rPr>
+              <a:t>Tech stack: Flask · AWS Africa · Next.js · Mapbox PMTiles · claude-haiku-4-5 ML model  ·  Open-source · Portable</a:t>
+            </a:r>
+            <a:endParaRPr lang="en-US" sz="800" dirty="0"/>
+          </a:p>
+        </p:txBody>
+      </p:sp>
+      <p:sp>
+        <p:nvSpPr>
+          <p:cNvPr id="46" name="Shape 44"/>
+          <p:cNvSpPr/>
+          <p:nvPr/>
+        </p:nvSpPr>
+        <p:spPr>
+          <a:xfrm>
+            <a:off x="365760" y="4608576"/>
+            <a:ext cx="8412480" cy="310896"/>
           </a:xfrm>
           <a:prstGeom prst="rect">
             <a:avLst/>
@@ -6816,14 +6958,14 @@
       </p:sp>
       <p:sp>
         <p:nvSpPr>
-          <p:cNvPr id="45" name="Text 43"/>
-          <p:cNvSpPr/>
-          <p:nvPr/>
-        </p:nvSpPr>
-        <p:spPr>
-          <a:xfrm>
-            <a:off x="502920" y="4572000"/>
-            <a:ext cx="8229600" cy="329184"/>
+          <p:cNvPr id="47" name="Text 45"/>
+          <p:cNvSpPr/>
+          <p:nvPr/>
+        </p:nvSpPr>
+        <p:spPr>
+          <a:xfrm>
+            <a:off x="502920" y="4626864"/>
+            <a:ext cx="8229600" cy="274320"/>
           </a:xfrm>
           <a:prstGeom prst="rect">
             <a:avLst/>
@@ -6855,7 +6997,7 @@
       </p:sp>
       <p:sp>
         <p:nvSpPr>
-          <p:cNvPr id="46" name="Shape 44"/>
+          <p:cNvPr id="48" name="Shape 46"/>
           <p:cNvSpPr/>
           <p:nvPr/>
         </p:nvSpPr>
@@ -6875,7 +7017,7 @@
       </p:sp>
       <p:sp>
         <p:nvSpPr>
-          <p:cNvPr id="47" name="Text 45"/>
+          <p:cNvPr id="49" name="Text 47"/>
           <p:cNvSpPr/>
           <p:nvPr/>
         </p:nvSpPr>
@@ -7992,7 +8134,7 @@
                 <a:ea typeface="Calibri" pitchFamily="34" charset="-122"/>
                 <a:cs typeface="Calibri" pitchFamily="34" charset="-120"/>
               </a:rPr>
-              <a:t>ENABLERS</a:t>
+              <a:t>FUNDERS &amp; VALIDATORS</a:t>
             </a:r>
             <a:endParaRPr lang="en-US" sz="800" dirty="0"/>
           </a:p>
@@ -8071,7 +8213,7 @@
                 <a:ea typeface="Calibri" pitchFamily="34" charset="-122"/>
                 <a:cs typeface="Calibri" pitchFamily="34" charset="-120"/>
               </a:rPr>
-              <a:t>1.7 million Nigerians in the US — motivated voters and donors</a:t>
+              <a:t>1.7M Nigerians in US — verify results from home wards via platform</a:t>
             </a:r>
             <a:endParaRPr lang="en-US" sz="900" dirty="0"/>
           </a:p>
@@ -8130,7 +8272,7 @@
                 <a:ea typeface="Calibri" pitchFamily="34" charset="-122"/>
                 <a:cs typeface="Calibri" pitchFamily="34" charset="-120"/>
               </a:rPr>
-              <a:t>USAID, Open Society: fund civic tech for electoral integrity</a:t>
+              <a:t>$50K funds Phase 1: NIDO, NANAF, state-chapter diaspora networks</a:t>
             </a:r>
             <a:endParaRPr lang="en-US" sz="900" dirty="0"/>
           </a:p>
@@ -8189,7 +8331,7 @@
                 <a:ea typeface="Calibri" pitchFamily="34" charset="-122"/>
                 <a:cs typeface="Calibri" pitchFamily="34" charset="-120"/>
               </a:rPr>
-              <a:t>Harvard Kennedy School: policy design and diaspora training</a:t>
+              <a:t>StayGIS LLC: fully independent — no party affiliation, open methodology</a:t>
             </a:r>
             <a:endParaRPr lang="en-US" sz="900" dirty="0"/>
           </a:p>
@@ -8248,7 +8390,7 @@
                 <a:ea typeface="Calibri" pitchFamily="34" charset="-122"/>
                 <a:cs typeface="Calibri" pitchFamily="34" charset="-120"/>
               </a:rPr>
-              <a:t>StayGIS LLC: technology development and deployment</a:t>
+              <a:t>Portable: Kenya, Ghana, Senegal legal frameworks already reviewed</a:t>
             </a:r>
             <a:endParaRPr lang="en-US" sz="900" dirty="0"/>
           </a:p>
@@ -8398,7 +8540,7 @@
                 <a:ea typeface="Calibri" pitchFamily="34" charset="-122"/>
                 <a:cs typeface="Calibri" pitchFamily="34" charset="-120"/>
               </a:rPr>
-              <a:t>90 Days from Policy Approval to Live Deployment</a:t>
+              <a:t>90 Days to Live Deployment  ·  Ekiti Jun 20  ·  Osun Aug 15  ·  National 2027</a:t>
             </a:r>
             <a:endParaRPr lang="en-US" sz="900" dirty="0"/>
           </a:p>
@@ -8666,7 +8808,7 @@
                 <a:ea typeface="Calibri" pitchFamily="34" charset="-122"/>
                 <a:cs typeface="Calibri" pitchFamily="34" charset="-120"/>
               </a:rPr>
-              <a:t>Publish 169k EC8A dataset as open data (CCIJ/Dataphyte)</a:t>
+              <a:t>Deploy E Don Kast with CCIJ 169k-form archive as live simulation</a:t>
             </a:r>
             <a:endParaRPr lang="en-US" sz="850" dirty="0"/>
           </a:p>
@@ -8725,7 +8867,7 @@
                 <a:ea typeface="Calibri" pitchFamily="34" charset="-122"/>
                 <a:cs typeface="Calibri" pitchFamily="34" charset="-120"/>
               </a:rPr>
-              <a:t>Deploy E Don Kast ward-level dashboard on Vercel</a:t>
+              <a:t>Obio-Akpor 2023 data proves pipeline — known outcome = ground truth</a:t>
             </a:r>
             <a:endParaRPr lang="en-US" sz="850" dirty="0"/>
           </a:p>
@@ -8784,7 +8926,7 @@
                 <a:ea typeface="Calibri" pitchFamily="34" charset="-122"/>
                 <a:cs typeface="Calibri" pitchFamily="34" charset="-120"/>
               </a:rPr>
-              <a:t>Sign INEC partnership MOU — IReV API access</a:t>
+              <a:t>Sign SERAP MOU — discrepancy outputs tribunal-ready</a:t>
             </a:r>
             <a:endParaRPr lang="en-US" sz="850" dirty="0"/>
           </a:p>
@@ -8902,7 +9044,7 @@
                 <a:ea typeface="Calibri" pitchFamily="34" charset="-122"/>
                 <a:cs typeface="Calibri" pitchFamily="34" charset="-120"/>
               </a:rPr>
-              <a:t>KPI: Dataset live + MOU signed</a:t>
+              <a:t>KPI: Dashboard live + SERAP MOU signed</a:t>
             </a:r>
             <a:endParaRPr lang="en-US" sz="850" dirty="0"/>
           </a:p>
@@ -9187,7 +9329,7 @@
                 <a:ea typeface="Calibri" pitchFamily="34" charset="-122"/>
                 <a:cs typeface="Calibri" pitchFamily="34" charset="-120"/>
               </a:rPr>
-              <a:t>Real-time aggregation vs official collation</a:t>
+              <a:t>Real-time aggregation vs official collation — live election</a:t>
             </a:r>
             <a:endParaRPr lang="en-US" sz="850" dirty="0"/>
           </a:p>
@@ -9590,7 +9732,7 @@
                 <a:ea typeface="Calibri" pitchFamily="34" charset="-122"/>
                 <a:cs typeface="Calibri" pitchFamily="34" charset="-120"/>
               </a:rPr>
-              <a:t>Scale to 3,000+ observers for Osun pilot</a:t>
+              <a:t>Scale to 3,000+ observers for Osun deployment</a:t>
             </a:r>
             <a:endParaRPr lang="en-US" sz="850" dirty="0"/>
           </a:p>
@@ -9649,7 +9791,7 @@
                 <a:ea typeface="Calibri" pitchFamily="34" charset="-122"/>
                 <a:cs typeface="Calibri" pitchFamily="34" charset="-120"/>
               </a:rPr>
-              <a:t>Submit accuracy report to INEC and Assembly</a:t>
+              <a:t>Submit accuracy report to INEC and National Assembly</a:t>
             </a:r>
             <a:endParaRPr lang="en-US" sz="850" dirty="0"/>
           </a:p>
@@ -9708,7 +9850,7 @@
                 <a:ea typeface="Calibri" pitchFamily="34" charset="-122"/>
                 <a:cs typeface="Calibri" pitchFamily="34" charset="-120"/>
               </a:rPr>
-              <a:t>Draft INEC Act amendment — mandatory EC8A disclosure</a:t>
+              <a:t>Draft INEC regulation — mandatory EC8A structured exports</a:t>
             </a:r>
             <a:endParaRPr lang="en-US" sz="850" dirty="0"/>
           </a:p>
@@ -9767,7 +9909,7 @@
                 <a:ea typeface="Calibri" pitchFamily="34" charset="-122"/>
                 <a:cs typeface="Calibri" pitchFamily="34" charset="-120"/>
               </a:rPr>
-              <a:t>Launch diaspora crowdfunding for 2027</a:t>
+              <a:t>Launch diaspora crowdfund for 2027 elections</a:t>
             </a:r>
             <a:endParaRPr lang="en-US" sz="850" dirty="0"/>
           </a:p>
@@ -9826,7 +9968,7 @@
                 <a:ea typeface="Calibri" pitchFamily="34" charset="-122"/>
                 <a:cs typeface="Calibri" pitchFamily="34" charset="-120"/>
               </a:rPr>
-              <a:t>KPI: Bill tabled; crowdfund at $50k+</a:t>
+              <a:t>KPI: Bill tabled; Phase 2 crowdfund at $50k+</a:t>
             </a:r>
             <a:endParaRPr lang="en-US" sz="850" dirty="0"/>
           </a:p>
@@ -10487,7 +10629,7 @@
                 <a:ea typeface="Trebuchet MS" pitchFamily="34" charset="-122"/>
                 <a:cs typeface="Trebuchet MS" pitchFamily="34" charset="-120"/>
               </a:rPr>
-              <a:t>$150k Seed Funding</a:t>
+              <a:t>$50k Phase 1 Seed</a:t>
             </a:r>
             <a:endParaRPr lang="en-US" sz="1300" dirty="0"/>
           </a:p>
@@ -10526,7 +10668,7 @@
                 <a:ea typeface="Calibri" pitchFamily="34" charset="-122"/>
                 <a:cs typeface="Calibri" pitchFamily="34" charset="-120"/>
               </a:rPr>
-              <a:t>Cover 2026 pilot elections (Ekiti Jun 20, Osun Aug 15) and platform hardening to production scale</a:t>
+              <a:t>Fund Obio-Akpor pilot via diaspora networks (NIDO, NANAF, state-chapter associations) — 90-day deployable</a:t>
             </a:r>
             <a:endParaRPr lang="en-US" sz="900" dirty="0"/>
           </a:p>

</xml_diff>